<commit_message>
Update PowerPoint for song #241 in FUBC - Українські
</commit_message>
<xml_diff>
--- a/fubc-ua/241-Боже мій, свої всі дні (Пісні Спасенних №240).pptx
+++ b/fubc-ua/241-Боже мій, свої всі дні (Пісні Спасенних №240).pptx
@@ -1696,7 +1696,7 @@
         </p:nvSpPr>
         <p:spPr>
           <a:xfrm>
-            <a:off x="1722247" y="4340352"/>
+            <a:off x="1821307" y="4340352"/>
             <a:ext cx="0" cy="594360"/>
           </a:xfrm>
           <a:prstGeom prst="line">
@@ -1719,7 +1719,7 @@
         </p:nvSpPr>
         <p:spPr>
           <a:xfrm>
-            <a:off x="10475849" y="4340352"/>
+            <a:off x="10376789" y="4340352"/>
             <a:ext cx="0" cy="594360"/>
           </a:xfrm>
           <a:prstGeom prst="line">
@@ -1742,8 +1742,8 @@
         </p:nvSpPr>
         <p:spPr>
           <a:xfrm>
-            <a:off x="10607929" y="4406392"/>
-            <a:ext cx="792480" cy="462280"/>
+            <a:off x="10475849" y="4317492"/>
+            <a:ext cx="1097280" cy="640080"/>
           </a:xfrm>
           <a:prstGeom prst="rect">
             <a:avLst/>
@@ -1759,9 +1759,9 @@
               <a:buNone/>
             </a:pPr>
             <a:r>
-              <a:rPr lang="en-US" sz="2600" b="1" dirty="0">
+              <a:rPr lang="en-US" sz="3600" b="1" dirty="0">
                 <a:solidFill>
-                  <a:srgbClr val="8A8A8A"/>
+                  <a:srgbClr val="BBBBBB"/>
                 </a:solidFill>
                 <a:latin typeface="Arial" pitchFamily="34" charset="0"/>
                 <a:ea typeface="Arial" pitchFamily="34" charset="-122"/>
@@ -1769,7 +1769,7 @@
               </a:rPr>
               <a:t>×2</a:t>
             </a:r>
-            <a:endParaRPr lang="en-US" sz="2600" dirty="0"/>
+            <a:endParaRPr lang="en-US" sz="3600" dirty="0"/>
           </a:p>
         </p:txBody>
       </p:sp>
@@ -1915,7 +1915,7 @@
         </p:nvSpPr>
         <p:spPr>
           <a:xfrm>
-            <a:off x="2051787" y="4340352"/>
+            <a:off x="2150847" y="4340352"/>
             <a:ext cx="0" cy="594360"/>
           </a:xfrm>
           <a:prstGeom prst="line">
@@ -1938,7 +1938,7 @@
         </p:nvSpPr>
         <p:spPr>
           <a:xfrm>
-            <a:off x="10146309" y="4340352"/>
+            <a:off x="10047249" y="4340352"/>
             <a:ext cx="0" cy="594360"/>
           </a:xfrm>
           <a:prstGeom prst="line">
@@ -1961,8 +1961,8 @@
         </p:nvSpPr>
         <p:spPr>
           <a:xfrm>
-            <a:off x="10278389" y="4406392"/>
-            <a:ext cx="792480" cy="462280"/>
+            <a:off x="10146309" y="4317492"/>
+            <a:ext cx="1097280" cy="640080"/>
           </a:xfrm>
           <a:prstGeom prst="rect">
             <a:avLst/>
@@ -1978,9 +1978,9 @@
               <a:buNone/>
             </a:pPr>
             <a:r>
-              <a:rPr lang="en-US" sz="2600" b="1" dirty="0">
+              <a:rPr lang="en-US" sz="3600" b="1" dirty="0">
                 <a:solidFill>
-                  <a:srgbClr val="8A8A8A"/>
+                  <a:srgbClr val="BBBBBB"/>
                 </a:solidFill>
                 <a:latin typeface="Arial" pitchFamily="34" charset="0"/>
                 <a:ea typeface="Arial" pitchFamily="34" charset="-122"/>
@@ -1988,7 +1988,7 @@
               </a:rPr>
               <a:t>×2</a:t>
             </a:r>
-            <a:endParaRPr lang="en-US" sz="2600" dirty="0"/>
+            <a:endParaRPr lang="en-US" sz="3600" dirty="0"/>
           </a:p>
         </p:txBody>
       </p:sp>
@@ -2134,7 +2134,7 @@
         </p:nvSpPr>
         <p:spPr>
           <a:xfrm>
-            <a:off x="1685265" y="4340352"/>
+            <a:off x="1784325" y="4340352"/>
             <a:ext cx="0" cy="594360"/>
           </a:xfrm>
           <a:prstGeom prst="line">
@@ -2157,7 +2157,7 @@
         </p:nvSpPr>
         <p:spPr>
           <a:xfrm>
-            <a:off x="10512831" y="4340352"/>
+            <a:off x="10413771" y="4340352"/>
             <a:ext cx="0" cy="594360"/>
           </a:xfrm>
           <a:prstGeom prst="line">
@@ -2180,8 +2180,8 @@
         </p:nvSpPr>
         <p:spPr>
           <a:xfrm>
-            <a:off x="10644911" y="4406392"/>
-            <a:ext cx="792480" cy="462280"/>
+            <a:off x="10512831" y="4317492"/>
+            <a:ext cx="1097280" cy="640080"/>
           </a:xfrm>
           <a:prstGeom prst="rect">
             <a:avLst/>
@@ -2197,9 +2197,9 @@
               <a:buNone/>
             </a:pPr>
             <a:r>
-              <a:rPr lang="en-US" sz="2600" b="1" dirty="0">
+              <a:rPr lang="en-US" sz="3600" b="1" dirty="0">
                 <a:solidFill>
-                  <a:srgbClr val="8A8A8A"/>
+                  <a:srgbClr val="BBBBBB"/>
                 </a:solidFill>
                 <a:latin typeface="Arial" pitchFamily="34" charset="0"/>
                 <a:ea typeface="Arial" pitchFamily="34" charset="-122"/>
@@ -2207,7 +2207,7 @@
               </a:rPr>
               <a:t>×2</a:t>
             </a:r>
-            <a:endParaRPr lang="en-US" sz="2600" dirty="0"/>
+            <a:endParaRPr lang="en-US" sz="3600" dirty="0"/>
           </a:p>
         </p:txBody>
       </p:sp>
@@ -2353,7 +2353,7 @@
         </p:nvSpPr>
         <p:spPr>
           <a:xfrm>
-            <a:off x="2040890" y="4340352"/>
+            <a:off x="2139950" y="4340352"/>
             <a:ext cx="0" cy="594360"/>
           </a:xfrm>
           <a:prstGeom prst="line">
@@ -2376,7 +2376,7 @@
         </p:nvSpPr>
         <p:spPr>
           <a:xfrm>
-            <a:off x="10157206" y="4340352"/>
+            <a:off x="10058146" y="4340352"/>
             <a:ext cx="0" cy="594360"/>
           </a:xfrm>
           <a:prstGeom prst="line">
@@ -2399,8 +2399,8 @@
         </p:nvSpPr>
         <p:spPr>
           <a:xfrm>
-            <a:off x="10289286" y="4406392"/>
-            <a:ext cx="792480" cy="462280"/>
+            <a:off x="10157206" y="4317492"/>
+            <a:ext cx="1097280" cy="640080"/>
           </a:xfrm>
           <a:prstGeom prst="rect">
             <a:avLst/>
@@ -2416,9 +2416,9 @@
               <a:buNone/>
             </a:pPr>
             <a:r>
-              <a:rPr lang="en-US" sz="2600" b="1" dirty="0">
+              <a:rPr lang="en-US" sz="3600" b="1" dirty="0">
                 <a:solidFill>
-                  <a:srgbClr val="8A8A8A"/>
+                  <a:srgbClr val="BBBBBB"/>
                 </a:solidFill>
                 <a:latin typeface="Arial" pitchFamily="34" charset="0"/>
                 <a:ea typeface="Arial" pitchFamily="34" charset="-122"/>
@@ -2426,7 +2426,7 @@
               </a:rPr>
               <a:t>×2</a:t>
             </a:r>
-            <a:endParaRPr lang="en-US" sz="2600" dirty="0"/>
+            <a:endParaRPr lang="en-US" sz="3600" dirty="0"/>
           </a:p>
         </p:txBody>
       </p:sp>
@@ -2572,7 +2572,7 @@
         </p:nvSpPr>
         <p:spPr>
           <a:xfrm>
-            <a:off x="1720266" y="4340352"/>
+            <a:off x="1819326" y="4340352"/>
             <a:ext cx="0" cy="594360"/>
           </a:xfrm>
           <a:prstGeom prst="line">
@@ -2595,7 +2595,7 @@
         </p:nvSpPr>
         <p:spPr>
           <a:xfrm>
-            <a:off x="10477830" y="4340352"/>
+            <a:off x="10378770" y="4340352"/>
             <a:ext cx="0" cy="594360"/>
           </a:xfrm>
           <a:prstGeom prst="line">
@@ -2618,8 +2618,8 @@
         </p:nvSpPr>
         <p:spPr>
           <a:xfrm>
-            <a:off x="10609910" y="4406392"/>
-            <a:ext cx="792480" cy="462280"/>
+            <a:off x="10477830" y="4317492"/>
+            <a:ext cx="1097280" cy="640080"/>
           </a:xfrm>
           <a:prstGeom prst="rect">
             <a:avLst/>
@@ -2635,9 +2635,9 @@
               <a:buNone/>
             </a:pPr>
             <a:r>
-              <a:rPr lang="en-US" sz="2600" b="1" dirty="0">
+              <a:rPr lang="en-US" sz="3600" b="1" dirty="0">
                 <a:solidFill>
-                  <a:srgbClr val="8A8A8A"/>
+                  <a:srgbClr val="BBBBBB"/>
                 </a:solidFill>
                 <a:latin typeface="Arial" pitchFamily="34" charset="0"/>
                 <a:ea typeface="Arial" pitchFamily="34" charset="-122"/>
@@ -2645,7 +2645,7 @@
               </a:rPr>
               <a:t>×2</a:t>
             </a:r>
-            <a:endParaRPr lang="en-US" sz="2600" dirty="0"/>
+            <a:endParaRPr lang="en-US" sz="3600" dirty="0"/>
           </a:p>
         </p:txBody>
       </p:sp>
@@ -2791,7 +2791,7 @@
         </p:nvSpPr>
         <p:spPr>
           <a:xfrm>
-            <a:off x="1782674" y="4340352"/>
+            <a:off x="1881734" y="4340352"/>
             <a:ext cx="0" cy="594360"/>
           </a:xfrm>
           <a:prstGeom prst="line">
@@ -2814,7 +2814,7 @@
         </p:nvSpPr>
         <p:spPr>
           <a:xfrm>
-            <a:off x="10415422" y="4340352"/>
+            <a:off x="10316362" y="4340352"/>
             <a:ext cx="0" cy="594360"/>
           </a:xfrm>
           <a:prstGeom prst="line">
@@ -2837,8 +2837,8 @@
         </p:nvSpPr>
         <p:spPr>
           <a:xfrm>
-            <a:off x="10547502" y="4406392"/>
-            <a:ext cx="792480" cy="462280"/>
+            <a:off x="10415422" y="4317492"/>
+            <a:ext cx="1097280" cy="640080"/>
           </a:xfrm>
           <a:prstGeom prst="rect">
             <a:avLst/>
@@ -2854,9 +2854,9 @@
               <a:buNone/>
             </a:pPr>
             <a:r>
-              <a:rPr lang="en-US" sz="2600" b="1" dirty="0">
+              <a:rPr lang="en-US" sz="3600" b="1" dirty="0">
                 <a:solidFill>
-                  <a:srgbClr val="8A8A8A"/>
+                  <a:srgbClr val="BBBBBB"/>
                 </a:solidFill>
                 <a:latin typeface="Arial" pitchFamily="34" charset="0"/>
                 <a:ea typeface="Arial" pitchFamily="34" charset="-122"/>
@@ -2864,7 +2864,7 @@
               </a:rPr>
               <a:t>×2</a:t>
             </a:r>
-            <a:endParaRPr lang="en-US" sz="2600" dirty="0"/>
+            <a:endParaRPr lang="en-US" sz="3600" dirty="0"/>
           </a:p>
         </p:txBody>
       </p:sp>

</xml_diff>